<commit_message>
Sync working tree: v2 course updates, assignments, decks, archify diagrams, prep and project files
Removes the retired v1 lessons/ tree and legacy decks; adds Week 1-2 assignments,
Day 3-5 archify diagrams, reference decks, and supporting scripts.

Co-Authored-By: Claude Sonnet 5 <noreply@anthropic.com>
</commit_message>
<xml_diff>
--- a/lessons-v2/day03/day03.pptx
+++ b/lessons-v2/day03/day03.pptx
@@ -26,9 +26,11 @@
     <p:sldId id="274" r:id="rId20"/>
     <p:sldId id="275" r:id="rId21"/>
     <p:sldId id="276" r:id="rId22"/>
+    <p:sldId id="277" r:id="rId23"/>
+    <p:sldId id="278" r:id="rId24"/>
   </p:sldIdLst>
   <p:notesMasterIdLst>
-    <p:notesMasterId r:id="rId23"/>
+    <p:notesMasterId r:id="rId25"/>
   </p:notesMasterIdLst>
   <p:sldSz cx="12192000" cy="6858000"/>
   <p:notesSz cx="6858000" cy="12192000"/>
@@ -527,20 +529,29 @@
 00:05 The problem (the roadmap)                            2
 00:07 IP — the street address                              6
 00:13 DO: find your IP + gateway                           5
-00:18 Private vs public IP                                 3
-00:21 NAT — one public address for the house               7
-00:28 MAC — the local label                                6
-00:34 DO: find your MAC                                    3
-00:37 Ports + client/server                                8
-00:45 DO: what's listening on your machine                 6
-00:51 A packet, put together                               4
-00:55 The 4-layer model                                    4
-00:59 The journey + DO: ping/traceroute                    9
-01:08 Attack &lt;-&gt; defence (ARP spoof, scanning, sniffing)   8
-01:16 Wrap + homework                                      6
-CUT FIRST IF SHORT: 4-layer slide -&gt; one sentence; ARP-spoof detail (keep the name); the
-ping "do it now".
+00:18 DHCP — where that number came from (live diagram)    2
+00:20 Private vs public IP                                 3
+00:23 NAT — one public address for the house               7
+00:30 MAC — the local label                                6
+00:36 DO: find your MAC                                    3
+00:39 Ports + client/server                                8
+00:47 DO: what's listening on your machine                 6
+00:53 A packet, put together                               4
+00:57 The 4-layer model                                    4
+01:01 The journey + DO: ping/traceroute                    9
+01:10 Attack &lt;-&gt; defence (ARP spoof, scanning, sniffing)   8
+01:18 What a firewall actually does (live diagram)         2
+01:20 Wrap + homework                                      6
+CUT FIRST IF SHORT: firewall slide -&gt; one sentence; DHCP slide -&gt; one sentence; 4-layer
+slide -&gt; one sentence; ARP-spoof detail (keep the name); the ping "do it now".
 NEVER CUT: the three addresses (IP/MAC/port), NAT, at least two "do it now" beats.
+LIVE DIAGRAMS (folder archify/ — open every file in its own browser tab BEFORE class; each has
+view buttons that step through the story, and a light/dark toggle for the projector):
+  01-three-addresses.html    -&gt; "The problem" slide, again on the Port slide (client/server view)
+  02-packet-journey-nat.html -&gt; NAT slide
+  03-packet-layers.html      -&gt; "A packet, put together" + "The 4-layer model"
+  04-dhcp-lease.html         -&gt; DHCP slide
+  05-firewall-decision.html  -&gt; firewall slide
 ONE ANALOGY (sanctioned extension of the kitchen): the POSTAL / DELIVERY system — the kitchen
 now orders supplies and ships out orders. Parcel=packet, street address=IP, next-leg label=MAC,
 department name=port, sorting office=router, front desk=NAT. Phone calls arrive tomorrow (TCP).</a:t>
@@ -586,6 +597,97 @@
 </file>
 
 <file path=ppt/notesSlides/notesSlide10.xml><?xml version="1.0" encoding="utf-8"?>
+<p:notes xmlns:a="http://schemas.openxmlformats.org/drawingml/2006/main" xmlns:r="http://schemas.openxmlformats.org/officeDocument/2006/relationships" xmlns:p="http://schemas.openxmlformats.org/presentationml/2006/main">
+  <p:cSld>
+    <p:spTree>
+      <p:nvGrpSpPr>
+        <p:cNvPr id="1" name=""/>
+        <p:cNvGrpSpPr/>
+        <p:nvPr/>
+      </p:nvGrpSpPr>
+      <p:grpSpPr>
+        <a:xfrm>
+          <a:off x="0" y="0"/>
+          <a:ext cx="0" cy="0"/>
+          <a:chOff x="0" y="0"/>
+          <a:chExt cx="0" cy="0"/>
+        </a:xfrm>
+      </p:grpSpPr>
+      <p:sp>
+        <p:nvSpPr>
+          <p:cNvPr id="2" name="Slide Image Placeholder 1"/>
+          <p:cNvSpPr>
+            <a:spLocks noGrp="1" noRot="1" noChangeAspect="1"/>
+          </p:cNvSpPr>
+          <p:nvPr>
+            <p:ph type="sldImg"/>
+          </p:nvPr>
+        </p:nvSpPr>
+        <p:spPr/>
+      </p:sp>
+      <p:sp>
+        <p:nvSpPr>
+          <p:cNvPr id="3" name="Notes Placeholder 2"/>
+          <p:cNvSpPr>
+            <a:spLocks noGrp="1"/>
+          </p:cNvSpPr>
+          <p:nvPr>
+            <p:ph type="body" idx="1"/>
+          </p:nvPr>
+        </p:nvSpPr>
+        <p:spPr/>
+        <p:txBody>
+          <a:bodyPr/>
+          <a:lstStyle/>
+          <a:p>
+            <a:r>
+              <a:rPr lang="en-US" dirty="0"/>
+              <a:t>Analogy: the parcel's street address (IP) never changes. At each sorting office they slap on a
+new "put on truck 7 / hand to postie Ravi" label (MAC) for the next leg.
+ARP = how a device learns "which MAC has IP 192.168.1.1" — one line now, matters at the attack slide.
+MISCONCEPTION: "my MAC identifies me on the internet." No — stripped at the first hop. Websites never see it.</a:t>
+            </a:r>
+            <a:endParaRPr lang="en-US" dirty="0"/>
+          </a:p>
+        </p:txBody>
+      </p:sp>
+      <p:sp>
+        <p:nvSpPr>
+          <p:cNvPr id="4" name="Slide Number Placeholder 3"/>
+          <p:cNvSpPr>
+            <a:spLocks noGrp="1"/>
+          </p:cNvSpPr>
+          <p:nvPr>
+            <p:ph type="sldNum" sz="quarter" idx="10"/>
+          </p:nvPr>
+        </p:nvSpPr>
+        <p:spPr/>
+        <p:txBody>
+          <a:bodyPr/>
+          <a:lstStyle/>
+          <a:p>
+            <a:fld id="{F7021451-1387-4CA6-816F-3879F97B5CBC}" type="slidenum">
+              <a:rPr lang="en-US"/>
+              <a:t>10</a:t>
+            </a:fld>
+            <a:endParaRPr lang="en-US"/>
+          </a:p>
+        </p:txBody>
+      </p:sp>
+    </p:spTree>
+    <p:extLst>
+      <p:ext uri="{BB962C8B-B14F-4D97-AF65-F5344CB8AC3E}">
+        <p14:creationId xmlns:p14="http://schemas.microsoft.com/office/powerpoint/2010/main" val="1024086991"/>
+      </p:ext>
+    </p:extLst>
+  </p:cSld>
+  <p:clrMapOvr>
+    <a:masterClrMapping/>
+  </p:clrMapOvr>
+</p:notes>
+</file>
+
+<file path=ppt/notesSlides/notesSlide11.xml><?xml version="1.0" encoding="utf-8"?>
 <p:notes xmlns:a="http://schemas.openxmlformats.org/drawingml/2006/main" xmlns:r="http://schemas.openxmlformats.org/officeDocument/2006/relationships" xmlns:p="http://schemas.openxmlformats.org/presentationml/2006/main">
   <p:cSld>
     <p:spTree>
@@ -655,7 +757,7 @@
           <a:p>
             <a:fld id="{F7021451-1387-4CA6-816F-3879F97B5CBC}" type="slidenum">
               <a:rPr lang="en-US"/>
-              <a:t>10</a:t>
+              <a:t>11</a:t>
             </a:fld>
             <a:endParaRPr lang="en-US"/>
           </a:p>
@@ -674,7 +776,7 @@
 </p:notes>
 </file>
 
-<file path=ppt/notesSlides/notesSlide11.xml><?xml version="1.0" encoding="utf-8"?>
+<file path=ppt/notesSlides/notesSlide12.xml><?xml version="1.0" encoding="utf-8"?>
 <p:notes xmlns:a="http://schemas.openxmlformats.org/drawingml/2006/main" xmlns:r="http://schemas.openxmlformats.org/officeDocument/2006/relationships" xmlns:p="http://schemas.openxmlformats.org/presentationml/2006/main">
   <p:cSld>
     <p:spTree>
@@ -721,6 +823,10 @@
             <a:r>
               <a:rPr lang="en-US" dirty="0"/>
               <a:t>Analogy: IP gets the parcel to the building; the port is the department name on it.
+Rows 3-4 are for RECOGNITION only — don't explain them. Students meet FTP/SSH properly on
+Day 13 when Nmap finds them; RDP/MySQL are "things that should never face the internet."
+LIVE DIAGRAM: archify/01-three-addresses.html, view "Client and server" — the browser's
+random source port vs the server's fixed 443. 30 seconds.
 CLIENT/SERVER (a must-land): the client opens the conversation and picks a random source port
 so it can match the reply; the server sits listening on a fixed, known port. "Listening on a
 port" = a process (Day 2! it has a PID) told the OS "give me anything arriving for port 80."</a:t>
@@ -746,7 +852,7 @@
           <a:p>
             <a:fld id="{F7021451-1387-4CA6-816F-3879F97B5CBC}" type="slidenum">
               <a:rPr lang="en-US"/>
-              <a:t>11</a:t>
+              <a:t>12</a:t>
             </a:fld>
             <a:endParaRPr lang="en-US"/>
           </a:p>
@@ -765,7 +871,7 @@
 </p:notes>
 </file>
 
-<file path=ppt/notesSlides/notesSlide12.xml><?xml version="1.0" encoding="utf-8"?>
+<file path=ppt/notesSlides/notesSlide13.xml><?xml version="1.0" encoding="utf-8"?>
 <p:notes xmlns:a="http://schemas.openxmlformats.org/drawingml/2006/main" xmlns:r="http://schemas.openxmlformats.org/officeDocument/2006/relationships" xmlns:p="http://schemas.openxmlformats.org/presentationml/2006/main">
   <p:cSld>
     <p:spTree>
@@ -837,7 +943,7 @@
           <a:p>
             <a:fld id="{F7021451-1387-4CA6-816F-3879F97B5CBC}" type="slidenum">
               <a:rPr lang="en-US"/>
-              <a:t>12</a:t>
+              <a:t>13</a:t>
             </a:fld>
             <a:endParaRPr lang="en-US"/>
           </a:p>
@@ -856,7 +962,7 @@
 </p:notes>
 </file>
 
-<file path=ppt/notesSlides/notesSlide13.xml><?xml version="1.0" encoding="utf-8"?>
+<file path=ppt/notesSlides/notesSlide14.xml><?xml version="1.0" encoding="utf-8"?>
 <p:notes xmlns:a="http://schemas.openxmlformats.org/drawingml/2006/main" xmlns:r="http://schemas.openxmlformats.org/officeDocument/2006/relationships" xmlns:p="http://schemas.openxmlformats.org/presentationml/2006/main">
   <p:cSld>
     <p:spTree>
@@ -904,7 +1010,9 @@
               <a:rPr lang="en-US" dirty="0"/>
               <a:t>This is the "envelopes inside envelopes" idea. Draw it as nested boxes on the board.
 The source port (51514) is a random high number your OS picks so it can match the reply.
-Don't say "encapsulation" unless asked — but that's the word.</a:t>
+Don't say "encapsulation" unless asked — but that's the word.
+LIVE DIAGRAM: archify/03-packet-layers.html, view 1 "Wrap the message" — same numbers as this
+slide (51514 -&gt; 443). Leave the tab open; views 2 and 3 belong to the next slide.</a:t>
             </a:r>
             <a:endParaRPr lang="en-US" dirty="0"/>
           </a:p>
@@ -927,7 +1035,7 @@
           <a:p>
             <a:fld id="{F7021451-1387-4CA6-816F-3879F97B5CBC}" type="slidenum">
               <a:rPr lang="en-US"/>
-              <a:t>13</a:t>
+              <a:t>14</a:t>
             </a:fld>
             <a:endParaRPr lang="en-US"/>
           </a:p>
@@ -946,7 +1054,7 @@
 </p:notes>
 </file>
 
-<file path=ppt/notesSlides/notesSlide14.xml><?xml version="1.0" encoding="utf-8"?>
+<file path=ppt/notesSlides/notesSlide15.xml><?xml version="1.0" encoding="utf-8"?>
 <p:notes xmlns:a="http://schemas.openxmlformats.org/drawingml/2006/main" xmlns:r="http://schemas.openxmlformats.org/officeDocument/2006/relationships" xmlns:p="http://schemas.openxmlformats.org/presentationml/2006/main">
   <p:cSld>
     <p:spTree>
@@ -994,6 +1102,9 @@
               <a:rPr lang="en-US" dirty="0"/>
               <a:t>Per the course standard: teach the 4-layer model, mention OSI-7 once, move on.
 Map it back to the packet slide: each row = one of the envelopes.
+LIVE DIAGRAM: archify/03-packet-layers.html, views 2 "At a router" (MAC swapped, IP kept) and
+3 "Deliver to process" (port -&gt; OS -&gt; the PID from Day 2). Then read the "Class check" card
+aloud — those three questions ARE the exit check.
 CUT-TO-ONE-SENTENCE if short: "messages are built in layers — link, internet, transport,
 application — each wrapping the next; we'll meet transport tomorrow."</a:t>
             </a:r>
@@ -1018,7 +1129,7 @@
           <a:p>
             <a:fld id="{F7021451-1387-4CA6-816F-3879F97B5CBC}" type="slidenum">
               <a:rPr lang="en-US"/>
-              <a:t>14</a:t>
+              <a:t>15</a:t>
             </a:fld>
             <a:endParaRPr lang="en-US"/>
           </a:p>
@@ -1037,7 +1148,7 @@
 </p:notes>
 </file>
 
-<file path=ppt/notesSlides/notesSlide15.xml><?xml version="1.0" encoding="utf-8"?>
+<file path=ppt/notesSlides/notesSlide16.xml><?xml version="1.0" encoding="utf-8"?>
 <p:notes xmlns:a="http://schemas.openxmlformats.org/drawingml/2006/main" xmlns:r="http://schemas.openxmlformats.org/officeDocument/2006/relationships" xmlns:p="http://schemas.openxmlformats.org/presentationml/2006/main">
   <p:cSld>
     <p:spTree>
@@ -1107,7 +1218,7 @@
           <a:p>
             <a:fld id="{F7021451-1387-4CA6-816F-3879F97B5CBC}" type="slidenum">
               <a:rPr lang="en-US"/>
-              <a:t>15</a:t>
+              <a:t>16</a:t>
             </a:fld>
             <a:endParaRPr lang="en-US"/>
           </a:p>
@@ -1126,7 +1237,7 @@
 </p:notes>
 </file>
 
-<file path=ppt/notesSlides/notesSlide16.xml><?xml version="1.0" encoding="utf-8"?>
+<file path=ppt/notesSlides/notesSlide17.xml><?xml version="1.0" encoding="utf-8"?>
 <p:notes xmlns:a="http://schemas.openxmlformats.org/drawingml/2006/main" xmlns:r="http://schemas.openxmlformats.org/officeDocument/2006/relationships" xmlns:p="http://schemas.openxmlformats.org/presentationml/2006/main">
   <p:cSld>
     <p:spTree>
@@ -1175,7 +1286,8 @@
               <a:t>Tie it together: the Day 1 trailer worked because attacker + victim were on the SAME LAN and
 the login was plain HTTP. ARP spoofing is how you'd get in the middle even on a switch.
 The fix that actually scales isn't "secure the LAN perfectly" — it's "assume the network is
-hostile and encrypt anyway." That's the whole reason for tomorrow's HTTPS lesson.</a:t>
+hostile and encrypt anyway." That's the whole reason for tomorrow's HTTPS lesson.
+"Host firewall" in the port-scanning row — next slide makes that concrete.</a:t>
             </a:r>
             <a:endParaRPr lang="en-US" dirty="0"/>
           </a:p>
@@ -1198,7 +1310,7 @@
           <a:p>
             <a:fld id="{F7021451-1387-4CA6-816F-3879F97B5CBC}" type="slidenum">
               <a:rPr lang="en-US"/>
-              <a:t>16</a:t>
+              <a:t>17</a:t>
             </a:fld>
             <a:endParaRPr lang="en-US"/>
           </a:p>
@@ -1217,7 +1329,100 @@
 </p:notes>
 </file>
 
-<file path=ppt/notesSlides/notesSlide17.xml><?xml version="1.0" encoding="utf-8"?>
+<file path=ppt/notesSlides/notesSlide18.xml><?xml version="1.0" encoding="utf-8"?>
+<p:notes xmlns:a="http://schemas.openxmlformats.org/drawingml/2006/main" xmlns:r="http://schemas.openxmlformats.org/officeDocument/2006/relationships" xmlns:p="http://schemas.openxmlformats.org/presentationml/2006/main">
+  <p:cSld>
+    <p:spTree>
+      <p:nvGrpSpPr>
+        <p:cNvPr id="1" name=""/>
+        <p:cNvGrpSpPr/>
+        <p:nvPr/>
+      </p:nvGrpSpPr>
+      <p:grpSpPr>
+        <a:xfrm>
+          <a:off x="0" y="0"/>
+          <a:ext cx="0" cy="0"/>
+          <a:chOff x="0" y="0"/>
+          <a:chExt cx="0" cy="0"/>
+        </a:xfrm>
+      </p:grpSpPr>
+      <p:sp>
+        <p:nvSpPr>
+          <p:cNvPr id="2" name="Slide Image Placeholder 1"/>
+          <p:cNvSpPr>
+            <a:spLocks noGrp="1" noRot="1" noChangeAspect="1"/>
+          </p:cNvSpPr>
+          <p:nvPr>
+            <p:ph type="sldImg"/>
+          </p:nvPr>
+        </p:nvSpPr>
+        <p:spPr/>
+      </p:sp>
+      <p:sp>
+        <p:nvSpPr>
+          <p:cNvPr id="3" name="Notes Placeholder 2"/>
+          <p:cNvSpPr>
+            <a:spLocks noGrp="1"/>
+          </p:cNvSpPr>
+          <p:nvPr>
+            <p:ph type="body" idx="1"/>
+          </p:nvPr>
+        </p:nvSpPr>
+        <p:spPr/>
+        <p:txBody>
+          <a:bodyPr/>
+          <a:lstStyle/>
+          <a:p>
+            <a:r>
+              <a:rPr lang="en-US" dirty="0"/>
+              <a:t>LIVE DIAGRAM: archify/05-firewall-decision.html — 3 views: arrives / allowed / dropped (~2 min).
+This is the "host firewall" from the port-scanning row made concrete. It does NOT read your
+data and does NOT know whether the data is malicious — it only decides which doors open for
+whom. NAT is not a firewall (teacher notes). "Filtered" in Nmap on Day 13 = this DROP branch.
+CUT to one sentence if short: "a firewall is a list of which ports open for which addresses;
+everything else is dropped silently."</a:t>
+            </a:r>
+            <a:endParaRPr lang="en-US" dirty="0"/>
+          </a:p>
+        </p:txBody>
+      </p:sp>
+      <p:sp>
+        <p:nvSpPr>
+          <p:cNvPr id="4" name="Slide Number Placeholder 3"/>
+          <p:cNvSpPr>
+            <a:spLocks noGrp="1"/>
+          </p:cNvSpPr>
+          <p:nvPr>
+            <p:ph type="sldNum" sz="quarter" idx="10"/>
+          </p:nvPr>
+        </p:nvSpPr>
+        <p:spPr/>
+        <p:txBody>
+          <a:bodyPr/>
+          <a:lstStyle/>
+          <a:p>
+            <a:fld id="{F7021451-1387-4CA6-816F-3879F97B5CBC}" type="slidenum">
+              <a:rPr lang="en-US"/>
+              <a:t>18</a:t>
+            </a:fld>
+            <a:endParaRPr lang="en-US"/>
+          </a:p>
+        </p:txBody>
+      </p:sp>
+    </p:spTree>
+    <p:extLst>
+      <p:ext uri="{BB962C8B-B14F-4D97-AF65-F5344CB8AC3E}">
+        <p14:creationId xmlns:p14="http://schemas.microsoft.com/office/powerpoint/2010/main" val="1024086991"/>
+      </p:ext>
+    </p:extLst>
+  </p:cSld>
+  <p:clrMapOvr>
+    <a:masterClrMapping/>
+  </p:clrMapOvr>
+</p:notes>
+</file>
+
+<file path=ppt/notesSlides/notesSlide19.xml><?xml version="1.0" encoding="utf-8"?>
 <p:notes xmlns:a="http://schemas.openxmlformats.org/drawingml/2006/main" xmlns:r="http://schemas.openxmlformats.org/officeDocument/2006/relationships" xmlns:p="http://schemas.openxmlformats.org/presentationml/2006/main">
   <p:cSld>
     <p:spTree>
@@ -1290,7 +1495,7 @@
           <a:p>
             <a:fld id="{F7021451-1387-4CA6-816F-3879F97B5CBC}" type="slidenum">
               <a:rPr lang="en-US"/>
-              <a:t>17</a:t>
+              <a:t>19</a:t>
             </a:fld>
             <a:endParaRPr lang="en-US"/>
           </a:p>
@@ -1309,7 +1514,95 @@
 </p:notes>
 </file>
 
-<file path=ppt/notesSlides/notesSlide18.xml><?xml version="1.0" encoding="utf-8"?>
+<file path=ppt/notesSlides/notesSlide2.xml><?xml version="1.0" encoding="utf-8"?>
+<p:notes xmlns:a="http://schemas.openxmlformats.org/drawingml/2006/main" xmlns:r="http://schemas.openxmlformats.org/officeDocument/2006/relationships" xmlns:p="http://schemas.openxmlformats.org/presentationml/2006/main">
+  <p:cSld>
+    <p:spTree>
+      <p:nvGrpSpPr>
+        <p:cNvPr id="1" name=""/>
+        <p:cNvGrpSpPr/>
+        <p:nvPr/>
+      </p:nvGrpSpPr>
+      <p:grpSpPr>
+        <a:xfrm>
+          <a:off x="0" y="0"/>
+          <a:ext cx="0" cy="0"/>
+          <a:chOff x="0" y="0"/>
+          <a:chExt cx="0" cy="0"/>
+        </a:xfrm>
+      </p:grpSpPr>
+      <p:sp>
+        <p:nvSpPr>
+          <p:cNvPr id="2" name="Slide Image Placeholder 1"/>
+          <p:cNvSpPr>
+            <a:spLocks noGrp="1" noRot="1" noChangeAspect="1"/>
+          </p:cNvSpPr>
+          <p:nvPr>
+            <p:ph type="sldImg"/>
+          </p:nvPr>
+        </p:nvSpPr>
+        <p:spPr/>
+      </p:sp>
+      <p:sp>
+        <p:nvSpPr>
+          <p:cNvPr id="3" name="Notes Placeholder 2"/>
+          <p:cNvSpPr>
+            <a:spLocks noGrp="1"/>
+          </p:cNvSpPr>
+          <p:nvPr>
+            <p:ph type="body" idx="1"/>
+          </p:nvPr>
+        </p:nvSpPr>
+        <p:spPr/>
+        <p:txBody>
+          <a:bodyPr/>
+          <a:lstStyle/>
+          <a:p>
+            <a:r>
+              <a:rPr lang="en-US" dirty="0"/>
+              <a:t>Learning Journey Check — one line each. Yesterday / Today / Tomorrow.</a:t>
+            </a:r>
+            <a:endParaRPr lang="en-US" dirty="0"/>
+          </a:p>
+        </p:txBody>
+      </p:sp>
+      <p:sp>
+        <p:nvSpPr>
+          <p:cNvPr id="4" name="Slide Number Placeholder 3"/>
+          <p:cNvSpPr>
+            <a:spLocks noGrp="1"/>
+          </p:cNvSpPr>
+          <p:nvPr>
+            <p:ph type="sldNum" sz="quarter" idx="10"/>
+          </p:nvPr>
+        </p:nvSpPr>
+        <p:spPr/>
+        <p:txBody>
+          <a:bodyPr/>
+          <a:lstStyle/>
+          <a:p>
+            <a:fld id="{F7021451-1387-4CA6-816F-3879F97B5CBC}" type="slidenum">
+              <a:rPr lang="en-US"/>
+              <a:t>2</a:t>
+            </a:fld>
+            <a:endParaRPr lang="en-US"/>
+          </a:p>
+        </p:txBody>
+      </p:sp>
+    </p:spTree>
+    <p:extLst>
+      <p:ext uri="{BB962C8B-B14F-4D97-AF65-F5344CB8AC3E}">
+        <p14:creationId xmlns:p14="http://schemas.microsoft.com/office/powerpoint/2010/main" val="1024086991"/>
+      </p:ext>
+    </p:extLst>
+  </p:cSld>
+  <p:clrMapOvr>
+    <a:masterClrMapping/>
+  </p:clrMapOvr>
+</p:notes>
+</file>
+
+<file path=ppt/notesSlides/notesSlide20.xml><?xml version="1.0" encoding="utf-8"?>
 <p:notes xmlns:a="http://schemas.openxmlformats.org/drawingml/2006/main" xmlns:r="http://schemas.openxmlformats.org/officeDocument/2006/relationships" xmlns:p="http://schemas.openxmlformats.org/presentationml/2006/main">
   <p:cSld>
     <p:spTree>
@@ -1380,7 +1673,7 @@
           <a:p>
             <a:fld id="{F7021451-1387-4CA6-816F-3879F97B5CBC}" type="slidenum">
               <a:rPr lang="en-US"/>
-              <a:t>18</a:t>
+              <a:t>20</a:t>
             </a:fld>
             <a:endParaRPr lang="en-US"/>
           </a:p>
@@ -1399,7 +1692,7 @@
 </p:notes>
 </file>
 
-<file path=ppt/notesSlides/notesSlide19.xml><?xml version="1.0" encoding="utf-8"?>
+<file path=ppt/notesSlides/notesSlide21.xml><?xml version="1.0" encoding="utf-8"?>
 <p:notes xmlns:a="http://schemas.openxmlformats.org/drawingml/2006/main" xmlns:r="http://schemas.openxmlformats.org/officeDocument/2006/relationships" xmlns:p="http://schemas.openxmlformats.org/presentationml/2006/main">
   <p:cSld>
     <p:spTree>
@@ -1468,7 +1761,7 @@
           <a:p>
             <a:fld id="{F7021451-1387-4CA6-816F-3879F97B5CBC}" type="slidenum">
               <a:rPr lang="en-US"/>
-              <a:t>19</a:t>
+              <a:t>21</a:t>
             </a:fld>
             <a:endParaRPr lang="en-US"/>
           </a:p>
@@ -1487,7 +1780,7 @@
 </p:notes>
 </file>
 
-<file path=ppt/notesSlides/notesSlide2.xml><?xml version="1.0" encoding="utf-8"?>
+<file path=ppt/notesSlides/notesSlide22.xml><?xml version="1.0" encoding="utf-8"?>
 <p:notes xmlns:a="http://schemas.openxmlformats.org/drawingml/2006/main" xmlns:r="http://schemas.openxmlformats.org/officeDocument/2006/relationships" xmlns:p="http://schemas.openxmlformats.org/presentationml/2006/main">
   <p:cSld>
     <p:spTree>
@@ -1533,7 +1826,7 @@
           <a:p>
             <a:r>
               <a:rPr lang="en-US" dirty="0"/>
-              <a:t>Learning Journey Check — one line each. Yesterday / Today / Tomorrow.</a:t>
+              <a:t>Due start of Day 4. Checklist grading in the week-1 student pack.</a:t>
             </a:r>
             <a:endParaRPr lang="en-US" dirty="0"/>
           </a:p>
@@ -1556,7 +1849,7 @@
           <a:p>
             <a:fld id="{F7021451-1387-4CA6-816F-3879F97B5CBC}" type="slidenum">
               <a:rPr lang="en-US"/>
-              <a:t>2</a:t>
+              <a:t>22</a:t>
             </a:fld>
             <a:endParaRPr lang="en-US"/>
           </a:p>
@@ -1575,95 +1868,7 @@
 </p:notes>
 </file>
 
-<file path=ppt/notesSlides/notesSlide20.xml><?xml version="1.0" encoding="utf-8"?>
-<p:notes xmlns:a="http://schemas.openxmlformats.org/drawingml/2006/main" xmlns:r="http://schemas.openxmlformats.org/officeDocument/2006/relationships" xmlns:p="http://schemas.openxmlformats.org/presentationml/2006/main">
-  <p:cSld>
-    <p:spTree>
-      <p:nvGrpSpPr>
-        <p:cNvPr id="1" name=""/>
-        <p:cNvGrpSpPr/>
-        <p:nvPr/>
-      </p:nvGrpSpPr>
-      <p:grpSpPr>
-        <a:xfrm>
-          <a:off x="0" y="0"/>
-          <a:ext cx="0" cy="0"/>
-          <a:chOff x="0" y="0"/>
-          <a:chExt cx="0" cy="0"/>
-        </a:xfrm>
-      </p:grpSpPr>
-      <p:sp>
-        <p:nvSpPr>
-          <p:cNvPr id="2" name="Slide Image Placeholder 1"/>
-          <p:cNvSpPr>
-            <a:spLocks noGrp="1" noRot="1" noChangeAspect="1"/>
-          </p:cNvSpPr>
-          <p:nvPr>
-            <p:ph type="sldImg"/>
-          </p:nvPr>
-        </p:nvSpPr>
-        <p:spPr/>
-      </p:sp>
-      <p:sp>
-        <p:nvSpPr>
-          <p:cNvPr id="3" name="Notes Placeholder 2"/>
-          <p:cNvSpPr>
-            <a:spLocks noGrp="1"/>
-          </p:cNvSpPr>
-          <p:nvPr>
-            <p:ph type="body" idx="1"/>
-          </p:nvPr>
-        </p:nvSpPr>
-        <p:spPr/>
-        <p:txBody>
-          <a:bodyPr/>
-          <a:lstStyle/>
-          <a:p>
-            <a:r>
-              <a:rPr lang="en-US" dirty="0"/>
-              <a:t>Due start of Day 4. Checklist grading in the week-1 student pack.</a:t>
-            </a:r>
-            <a:endParaRPr lang="en-US" dirty="0"/>
-          </a:p>
-        </p:txBody>
-      </p:sp>
-      <p:sp>
-        <p:nvSpPr>
-          <p:cNvPr id="4" name="Slide Number Placeholder 3"/>
-          <p:cNvSpPr>
-            <a:spLocks noGrp="1"/>
-          </p:cNvSpPr>
-          <p:nvPr>
-            <p:ph type="sldNum" sz="quarter" idx="10"/>
-          </p:nvPr>
-        </p:nvSpPr>
-        <p:spPr/>
-        <p:txBody>
-          <a:bodyPr/>
-          <a:lstStyle/>
-          <a:p>
-            <a:fld id="{F7021451-1387-4CA6-816F-3879F97B5CBC}" type="slidenum">
-              <a:rPr lang="en-US"/>
-              <a:t>20</a:t>
-            </a:fld>
-            <a:endParaRPr lang="en-US"/>
-          </a:p>
-        </p:txBody>
-      </p:sp>
-    </p:spTree>
-    <p:extLst>
-      <p:ext uri="{BB962C8B-B14F-4D97-AF65-F5344CB8AC3E}">
-        <p14:creationId xmlns:p14="http://schemas.microsoft.com/office/powerpoint/2010/main" val="1024086991"/>
-      </p:ext>
-    </p:extLst>
-  </p:cSld>
-  <p:clrMapOvr>
-    <a:masterClrMapping/>
-  </p:clrMapOvr>
-</p:notes>
-</file>
-
-<file path=ppt/notesSlides/notesSlide21.xml><?xml version="1.0" encoding="utf-8"?>
+<file path=ppt/notesSlides/notesSlide23.xml><?xml version="1.0" encoding="utf-8"?>
 <p:notes xmlns:a="http://schemas.openxmlformats.org/drawingml/2006/main" xmlns:r="http://schemas.openxmlformats.org/officeDocument/2006/relationships" xmlns:p="http://schemas.openxmlformats.org/presentationml/2006/main">
   <p:cSld>
     <p:spTree>
@@ -1733,7 +1938,7 @@
           <a:p>
             <a:fld id="{F7021451-1387-4CA6-816F-3879F97B5CBC}" type="slidenum">
               <a:rPr lang="en-US"/>
-              <a:t>21</a:t>
+              <a:t>23</a:t>
             </a:fld>
             <a:endParaRPr lang="en-US"/>
           </a:p>
@@ -1890,7 +2095,9 @@
           <a:p>
             <a:r>
               <a:rPr lang="en-US" dirty="0"/>
-              <a:t>Keep this to ~2 min. It's the roadmap for the next section. Then straight into IP.</a:t>
+              <a:t>Keep this to ~2 min. It's the roadmap for the next section. Then straight into IP.
+LIVE DIAGRAM: archify/01-three-addresses.html, view "Three jobs" — one pass, 30 seconds, just
+so they have seen the three labels side by side before we take them one at a time.</a:t>
             </a:r>
             <a:endParaRPr lang="en-US" dirty="0"/>
           </a:p>
@@ -2068,7 +2275,8 @@
             <a:r>
               <a:rPr lang="en-US" dirty="0"/>
               <a:t>90 seconds. Walk the room. Almost everyone: 192.168.x.x or 10.x.x.x, gateway usually .1 or .254.
-Ask two students to call theirs out — note they're similar/identical. That's the next slide.</a:t>
+Ask two students to call theirs out — note they're similar/identical. That's the slide after
+next. First: "who typed that number in?" Nobody. Next slide.</a:t>
             </a:r>
             <a:endParaRPr lang="en-US" dirty="0"/>
           </a:p>
@@ -2111,6 +2319,100 @@
 </file>
 
 <file path=ppt/notesSlides/notesSlide7.xml><?xml version="1.0" encoding="utf-8"?>
+<p:notes xmlns:a="http://schemas.openxmlformats.org/drawingml/2006/main" xmlns:r="http://schemas.openxmlformats.org/officeDocument/2006/relationships" xmlns:p="http://schemas.openxmlformats.org/presentationml/2006/main">
+  <p:cSld>
+    <p:spTree>
+      <p:nvGrpSpPr>
+        <p:cNvPr id="1" name=""/>
+        <p:cNvGrpSpPr/>
+        <p:nvPr/>
+      </p:nvGrpSpPr>
+      <p:grpSpPr>
+        <a:xfrm>
+          <a:off x="0" y="0"/>
+          <a:ext cx="0" cy="0"/>
+          <a:chOff x="0" y="0"/>
+          <a:chExt cx="0" cy="0"/>
+        </a:xfrm>
+      </p:grpSpPr>
+      <p:sp>
+        <p:nvSpPr>
+          <p:cNvPr id="2" name="Slide Image Placeholder 1"/>
+          <p:cNvSpPr>
+            <a:spLocks noGrp="1" noRot="1" noChangeAspect="1"/>
+          </p:cNvSpPr>
+          <p:nvPr>
+            <p:ph type="sldImg"/>
+          </p:nvPr>
+        </p:nvSpPr>
+        <p:spPr/>
+      </p:sp>
+      <p:sp>
+        <p:nvSpPr>
+          <p:cNvPr id="3" name="Notes Placeholder 2"/>
+          <p:cNvSpPr>
+            <a:spLocks noGrp="1"/>
+          </p:cNvSpPr>
+          <p:nvPr>
+            <p:ph type="body" idx="1"/>
+          </p:nvPr>
+        </p:nvSpPr>
+        <p:spPr/>
+        <p:txBody>
+          <a:bodyPr/>
+          <a:lstStyle/>
+          <a:p>
+            <a:r>
+              <a:rPr lang="en-US" dirty="0"/>
+              <a:t>LIVE DIAGRAM: archify/04-dhcp-lease.html — click through the 3 views (~2 min).
+The point: nobody configured your laptop. The router's DHCP service handed out the IP, the
+gateway (.1) AND the DNS server in one go — that is why "find your gateway" just worked.
+169.254.x.x = DISCOVER got no answer (broken wifi, not a broken laptop).
+Security hook for later: a rogue DHCP server on the LAN can hand out a lying gateway — same
+family as ARP spoofing on the attack slide.
+CUT to one sentence if short: "the router leased you that address automatically."</a:t>
+            </a:r>
+            <a:endParaRPr lang="en-US" dirty="0"/>
+          </a:p>
+        </p:txBody>
+      </p:sp>
+      <p:sp>
+        <p:nvSpPr>
+          <p:cNvPr id="4" name="Slide Number Placeholder 3"/>
+          <p:cNvSpPr>
+            <a:spLocks noGrp="1"/>
+          </p:cNvSpPr>
+          <p:nvPr>
+            <p:ph type="sldNum" sz="quarter" idx="10"/>
+          </p:nvPr>
+        </p:nvSpPr>
+        <p:spPr/>
+        <p:txBody>
+          <a:bodyPr/>
+          <a:lstStyle/>
+          <a:p>
+            <a:fld id="{F7021451-1387-4CA6-816F-3879F97B5CBC}" type="slidenum">
+              <a:rPr lang="en-US"/>
+              <a:t>7</a:t>
+            </a:fld>
+            <a:endParaRPr lang="en-US"/>
+          </a:p>
+        </p:txBody>
+      </p:sp>
+    </p:spTree>
+    <p:extLst>
+      <p:ext uri="{BB962C8B-B14F-4D97-AF65-F5344CB8AC3E}">
+        <p14:creationId xmlns:p14="http://schemas.microsoft.com/office/powerpoint/2010/main" val="1024086991"/>
+      </p:ext>
+    </p:extLst>
+  </p:cSld>
+  <p:clrMapOvr>
+    <a:masterClrMapping/>
+  </p:clrMapOvr>
+</p:notes>
+</file>
+
+<file path=ppt/notesSlides/notesSlide8.xml><?xml version="1.0" encoding="utf-8"?>
 <p:notes xmlns:a="http://schemas.openxmlformats.org/drawingml/2006/main" xmlns:r="http://schemas.openxmlformats.org/officeDocument/2006/relationships" xmlns:p="http://schemas.openxmlformats.org/presentationml/2006/main">
   <p:cSld>
     <p:spTree>
@@ -2181,7 +2483,7 @@
           <a:p>
             <a:fld id="{F7021451-1387-4CA6-816F-3879F97B5CBC}" type="slidenum">
               <a:rPr lang="en-US"/>
-              <a:t>7</a:t>
+              <a:t>8</a:t>
             </a:fld>
             <a:endParaRPr lang="en-US"/>
           </a:p>
@@ -2200,7 +2502,7 @@
 </p:notes>
 </file>
 
-<file path=ppt/notesSlides/notesSlide8.xml><?xml version="1.0" encoding="utf-8"?>
+<file path=ppt/notesSlides/notesSlide9.xml><?xml version="1.0" encoding="utf-8"?>
 <p:notes xmlns:a="http://schemas.openxmlformats.org/drawingml/2006/main" xmlns:r="http://schemas.openxmlformats.org/officeDocument/2006/relationships" xmlns:p="http://schemas.openxmlformats.org/presentationml/2006/main">
   <p:cSld>
     <p:spTree>
@@ -2251,99 +2553,10 @@
 call it out explicitly, it's the homework question.
 Analogy: the whole household sends mail via one front-desk address; the front desk (router)
 keeps a log so replies get to the right person.
+LIVE DIAGRAM: archify/02-packet-journey-nat.html — 3 views: inside the home / NAT boundary /
+reply returns. Use the "Reply returns" view to answer "how does the reply find MY laptop?"
 Security note for later: NAT accidentally hides internal devices — not a firewall, but it
 means the internet can't directly address your laptop.</a:t>
-            </a:r>
-            <a:endParaRPr lang="en-US" dirty="0"/>
-          </a:p>
-        </p:txBody>
-      </p:sp>
-      <p:sp>
-        <p:nvSpPr>
-          <p:cNvPr id="4" name="Slide Number Placeholder 3"/>
-          <p:cNvSpPr>
-            <a:spLocks noGrp="1"/>
-          </p:cNvSpPr>
-          <p:nvPr>
-            <p:ph type="sldNum" sz="quarter" idx="10"/>
-          </p:nvPr>
-        </p:nvSpPr>
-        <p:spPr/>
-        <p:txBody>
-          <a:bodyPr/>
-          <a:lstStyle/>
-          <a:p>
-            <a:fld id="{F7021451-1387-4CA6-816F-3879F97B5CBC}" type="slidenum">
-              <a:rPr lang="en-US"/>
-              <a:t>8</a:t>
-            </a:fld>
-            <a:endParaRPr lang="en-US"/>
-          </a:p>
-        </p:txBody>
-      </p:sp>
-    </p:spTree>
-    <p:extLst>
-      <p:ext uri="{BB962C8B-B14F-4D97-AF65-F5344CB8AC3E}">
-        <p14:creationId xmlns:p14="http://schemas.microsoft.com/office/powerpoint/2010/main" val="1024086991"/>
-      </p:ext>
-    </p:extLst>
-  </p:cSld>
-  <p:clrMapOvr>
-    <a:masterClrMapping/>
-  </p:clrMapOvr>
-</p:notes>
-</file>
-
-<file path=ppt/notesSlides/notesSlide9.xml><?xml version="1.0" encoding="utf-8"?>
-<p:notes xmlns:a="http://schemas.openxmlformats.org/drawingml/2006/main" xmlns:r="http://schemas.openxmlformats.org/officeDocument/2006/relationships" xmlns:p="http://schemas.openxmlformats.org/presentationml/2006/main">
-  <p:cSld>
-    <p:spTree>
-      <p:nvGrpSpPr>
-        <p:cNvPr id="1" name=""/>
-        <p:cNvGrpSpPr/>
-        <p:nvPr/>
-      </p:nvGrpSpPr>
-      <p:grpSpPr>
-        <a:xfrm>
-          <a:off x="0" y="0"/>
-          <a:ext cx="0" cy="0"/>
-          <a:chOff x="0" y="0"/>
-          <a:chExt cx="0" cy="0"/>
-        </a:xfrm>
-      </p:grpSpPr>
-      <p:sp>
-        <p:nvSpPr>
-          <p:cNvPr id="2" name="Slide Image Placeholder 1"/>
-          <p:cNvSpPr>
-            <a:spLocks noGrp="1" noRot="1" noChangeAspect="1"/>
-          </p:cNvSpPr>
-          <p:nvPr>
-            <p:ph type="sldImg"/>
-          </p:nvPr>
-        </p:nvSpPr>
-        <p:spPr/>
-      </p:sp>
-      <p:sp>
-        <p:nvSpPr>
-          <p:cNvPr id="3" name="Notes Placeholder 2"/>
-          <p:cNvSpPr>
-            <a:spLocks noGrp="1"/>
-          </p:cNvSpPr>
-          <p:nvPr>
-            <p:ph type="body" idx="1"/>
-          </p:nvPr>
-        </p:nvSpPr>
-        <p:spPr/>
-        <p:txBody>
-          <a:bodyPr/>
-          <a:lstStyle/>
-          <a:p>
-            <a:r>
-              <a:rPr lang="en-US" dirty="0"/>
-              <a:t>Analogy: the parcel's street address (IP) never changes. At each sorting office they slap on a
-new "put on truck 7 / hand to postie Ravi" label (MAC) for the next leg.
-ARP = how a device learns "which MAC has IP 192.168.1.1" — one line now, matters at the attack slide.
-MISCONCEPTION: "my MAC identifies me on the internet." No — stripped at the first hop. Websites never see it.</a:t>
             </a:r>
             <a:endParaRPr lang="en-US" dirty="0"/>
           </a:p>
@@ -3202,6 +3415,84 @@
 <file path=ppt/slides/slide21.xml><?xml version="1.0" encoding="utf-8"?>
 <p:sld xmlns:a="http://schemas.openxmlformats.org/drawingml/2006/main" xmlns:r="http://schemas.openxmlformats.org/officeDocument/2006/relationships" xmlns:p="http://schemas.openxmlformats.org/presentationml/2006/main">
   <p:cSld name="Slide 21">
+    <p:bg>
+      <p:bgPr>
+        <a:blipFill dpi="0" rotWithShape="1">
+          <a:blip r:embed="rId1">
+            <a:lum/>
+          </a:blip>
+          <a:srcRect/>
+          <a:stretch>
+            <a:fillRect/>
+          </a:stretch>
+        </a:blipFill>
+        <a:effectLst/>
+      </p:bgPr>
+    </p:bg>
+    <p:spTree>
+      <p:nvGrpSpPr>
+        <p:cNvPr id="1" name=""/>
+        <p:cNvGrpSpPr/>
+        <p:nvPr/>
+      </p:nvGrpSpPr>
+      <p:grpSpPr>
+        <a:xfrm>
+          <a:off x="0" y="0"/>
+          <a:ext cx="0" cy="0"/>
+          <a:chOff x="0" y="0"/>
+          <a:chExt cx="0" cy="0"/>
+        </a:xfrm>
+      </p:grpSpPr>
+    </p:spTree>
+  </p:cSld>
+  <p:clrMapOvr>
+    <a:masterClrMapping/>
+  </p:clrMapOvr>
+</p:sld>
+</file>
+
+<file path=ppt/slides/slide22.xml><?xml version="1.0" encoding="utf-8"?>
+<p:sld xmlns:a="http://schemas.openxmlformats.org/drawingml/2006/main" xmlns:r="http://schemas.openxmlformats.org/officeDocument/2006/relationships" xmlns:p="http://schemas.openxmlformats.org/presentationml/2006/main">
+  <p:cSld name="Slide 22">
+    <p:bg>
+      <p:bgPr>
+        <a:blipFill dpi="0" rotWithShape="1">
+          <a:blip r:embed="rId1">
+            <a:lum/>
+          </a:blip>
+          <a:srcRect/>
+          <a:stretch>
+            <a:fillRect/>
+          </a:stretch>
+        </a:blipFill>
+        <a:effectLst/>
+      </p:bgPr>
+    </p:bg>
+    <p:spTree>
+      <p:nvGrpSpPr>
+        <p:cNvPr id="1" name=""/>
+        <p:cNvGrpSpPr/>
+        <p:nvPr/>
+      </p:nvGrpSpPr>
+      <p:grpSpPr>
+        <a:xfrm>
+          <a:off x="0" y="0"/>
+          <a:ext cx="0" cy="0"/>
+          <a:chOff x="0" y="0"/>
+          <a:chExt cx="0" cy="0"/>
+        </a:xfrm>
+      </p:grpSpPr>
+    </p:spTree>
+  </p:cSld>
+  <p:clrMapOvr>
+    <a:masterClrMapping/>
+  </p:clrMapOvr>
+</p:sld>
+</file>
+
+<file path=ppt/slides/slide23.xml><?xml version="1.0" encoding="utf-8"?>
+<p:sld xmlns:a="http://schemas.openxmlformats.org/drawingml/2006/main" xmlns:r="http://schemas.openxmlformats.org/officeDocument/2006/relationships" xmlns:p="http://schemas.openxmlformats.org/presentationml/2006/main">
+  <p:cSld name="Slide 23">
     <p:bg>
       <p:bgPr>
         <a:blipFill dpi="0" rotWithShape="1">

</xml_diff>